<commit_message>
Fix file picker and folder picker
</commit_message>
<xml_diff>
--- a/6_templates/output.pptx
+++ b/6_templates/output.pptx
@@ -17,8 +17,6 @@
     <p:sldId id="630" r:id="rId16"/>
     <p:sldId id="631" r:id="rId17"/>
     <p:sldId id="632" r:id="rId18"/>
-    <p:sldId id="633" r:id="rId19"/>
-    <p:sldId id="634" r:id="rId20"/>
   </p:sldIdLst>
   <p:sldSz cx="10691813" cy="7559675"/>
   <p:notesSz cx="6858000" cy="9144000"/>
@@ -4794,14 +4792,14 @@
           <a:lstStyle/>
           <a:p>
             <a:r>
-              <a:t>UPS-15-ISOTX-C1-IST-DAY4__0_config_composite_Active_Power</a:t>
+              <a:t>UPS-15-ISOTX-C1-IST-DAY4__5_config_composite_Frequency</a:t>
             </a:r>
           </a:p>
         </p:txBody>
       </p:sp>
       <p:pic>
         <p:nvPicPr>
-          <p:cNvPr id="4" name="Picture 3" descr="UPS-15-ISOTX-C1-IST-DAY4__0_config_composite_Active_Power.png"/>
+          <p:cNvPr id="4" name="Picture 3" descr="UPS-15-ISOTX-C1-IST-DAY4__5_config_composite_Frequency.png"/>
           <p:cNvPicPr>
             <a:picLocks noChangeAspect="1"/>
           </p:cNvPicPr>
@@ -4920,14 +4918,14 @@
           <a:lstStyle/>
           <a:p>
             <a:r>
-              <a:t>UPS-15-ISOTX-C1-IST-DAY4__0_config_composite_Active_Power_v_1</a:t>
+              <a:t>UPS-15-ISOTX-C1-IST-DAY4__Active_Power</a:t>
             </a:r>
           </a:p>
         </p:txBody>
       </p:sp>
       <p:pic>
         <p:nvPicPr>
-          <p:cNvPr id="4" name="Picture 3" descr="UPS-15-ISOTX-C1-IST-DAY4__0_config_composite_Active_Power_v_1.png"/>
+          <p:cNvPr id="4" name="Picture 3" descr="UPS-15-ISOTX-C1-IST-DAY4__Active_Power.png"/>
           <p:cNvPicPr>
             <a:picLocks noChangeAspect="1"/>
           </p:cNvPicPr>
@@ -5046,140 +5044,14 @@
           <a:lstStyle/>
           <a:p>
             <a:r>
-              <a:t>UPS-15-ISOTX-C1-IST-DAY4__5_config_composite_Frequency</a:t>
+              <a:t>UPS-15-ISOTX-C1-IST-DAY4__3_confcomposite_Current</a:t>
             </a:r>
           </a:p>
         </p:txBody>
       </p:sp>
       <p:pic>
         <p:nvPicPr>
-          <p:cNvPr id="4" name="Picture 3" descr="UPS-15-ISOTX-C1-IST-DAY4__5_config_composite_Frequency.png"/>
-          <p:cNvPicPr>
-            <a:picLocks noChangeAspect="1"/>
-          </p:cNvPicPr>
-          <p:nvPr/>
-        </p:nvPicPr>
-        <p:blipFill>
-          <a:blip r:embed="rId2"/>
-          <a:stretch>
-            <a:fillRect/>
-          </a:stretch>
-        </p:blipFill>
-        <p:spPr>
-          <a:xfrm>
-            <a:off x="910809" y="1662113"/>
-            <a:ext cx="8971843" cy="5046662"/>
-          </a:xfrm>
-          <a:prstGeom prst="rect">
-            <a:avLst/>
-          </a:prstGeom>
-        </p:spPr>
-      </p:pic>
-    </p:spTree>
-  </p:cSld>
-  <p:clrMapOvr>
-    <a:masterClrMapping/>
-  </p:clrMapOvr>
-</p:sld>
-</file>
-
-<file path=ppt/slides/slide7.xml><?xml version="1.0" encoding="utf-8"?>
-<p:sld xmlns:a="http://schemas.openxmlformats.org/drawingml/2006/main" xmlns:p="http://schemas.openxmlformats.org/presentationml/2006/main" xmlns:r="http://schemas.openxmlformats.org/officeDocument/2006/relationships">
-  <p:cSld>
-    <p:spTree>
-      <p:nvGrpSpPr>
-        <p:cNvPr id="1" name=""/>
-        <p:cNvGrpSpPr/>
-        <p:nvPr/>
-      </p:nvGrpSpPr>
-      <p:grpSpPr/>
-      <p:sp>
-        <p:nvSpPr>
-          <p:cNvPr id="3" name="Title 2"/>
-          <p:cNvSpPr>
-            <a:spLocks noGrp="1"/>
-          </p:cNvSpPr>
-          <p:nvPr>
-            <p:ph type="title"/>
-          </p:nvPr>
-        </p:nvSpPr>
-        <p:spPr/>
-        <p:txBody>
-          <a:bodyPr/>
-          <a:lstStyle/>
-          <a:p>
-            <a:r>
-              <a:t>UPS-15-ISOTX-C1-IST-DAY4__3_config_composite_Current</a:t>
-            </a:r>
-          </a:p>
-        </p:txBody>
-      </p:sp>
-      <p:pic>
-        <p:nvPicPr>
-          <p:cNvPr id="4" name="Picture 3" descr="UPS-15-ISOTX-C1-IST-DAY4__3_config_composite_Current.png"/>
-          <p:cNvPicPr>
-            <a:picLocks noChangeAspect="1"/>
-          </p:cNvPicPr>
-          <p:nvPr/>
-        </p:nvPicPr>
-        <p:blipFill>
-          <a:blip r:embed="rId2"/>
-          <a:stretch>
-            <a:fillRect/>
-          </a:stretch>
-        </p:blipFill>
-        <p:spPr>
-          <a:xfrm>
-            <a:off x="910809" y="1662113"/>
-            <a:ext cx="8971843" cy="5046662"/>
-          </a:xfrm>
-          <a:prstGeom prst="rect">
-            <a:avLst/>
-          </a:prstGeom>
-        </p:spPr>
-      </p:pic>
-    </p:spTree>
-  </p:cSld>
-  <p:clrMapOvr>
-    <a:masterClrMapping/>
-  </p:clrMapOvr>
-</p:sld>
-</file>
-
-<file path=ppt/slides/slide8.xml><?xml version="1.0" encoding="utf-8"?>
-<p:sld xmlns:a="http://schemas.openxmlformats.org/drawingml/2006/main" xmlns:p="http://schemas.openxmlformats.org/presentationml/2006/main" xmlns:r="http://schemas.openxmlformats.org/officeDocument/2006/relationships">
-  <p:cSld>
-    <p:spTree>
-      <p:nvGrpSpPr>
-        <p:cNvPr id="1" name=""/>
-        <p:cNvGrpSpPr/>
-        <p:nvPr/>
-      </p:nvGrpSpPr>
-      <p:grpSpPr/>
-      <p:sp>
-        <p:nvSpPr>
-          <p:cNvPr id="3" name="Title 2"/>
-          <p:cNvSpPr>
-            <a:spLocks noGrp="1"/>
-          </p:cNvSpPr>
-          <p:nvPr>
-            <p:ph type="title"/>
-          </p:nvPr>
-        </p:nvSpPr>
-        <p:spPr/>
-        <p:txBody>
-          <a:bodyPr/>
-          <a:lstStyle/>
-          <a:p>
-            <a:r>
-              <a:t>UPS-15-ISOTX-C1-IST-DAY4__6_config_composite_THD_Voltage</a:t>
-            </a:r>
-          </a:p>
-        </p:txBody>
-      </p:sp>
-      <p:pic>
-        <p:nvPicPr>
-          <p:cNvPr id="4" name="Picture 3" descr="UPS-15-ISOTX-C1-IST-DAY4__6_config_composite_THD_Voltage.png"/>
+          <p:cNvPr id="4" name="Picture 3" descr="UPS-15-ISOTX-C1-IST-DAY4__3_confcomposite_Current.png"/>
           <p:cNvPicPr>
             <a:picLocks noChangeAspect="1"/>
           </p:cNvPicPr>

</xml_diff>